<commit_message>
fix(stability): reconnect frontend routing and regression gates
Make API/document ownership explicit, restore scoped waiver history, and exercise real query failure/refetch behavior in the complete CI suite. Start a verified UI server before browser checks and retain honest outcomes.

Refs #531, #532, #533, #534, #535, #536

Co-authored-by: Copilot <223556219+Copilot@users.noreply.github.com>
</commit_message>
<xml_diff>
--- a/docs/uat/uat_overview.pptx
+++ b/docs/uat/uat_overview.pptx
@@ -6778,14 +6778,14 @@
       </p:grpSpPr>
       <p:pic>
         <p:nvPicPr>
-          <p:cNvPr id="2" name="Picture 1" descr="image.png"/>
+          <p:cNvPr id="2" name="Picture 1" descr="uat_commissioner_waiver_rules_page.png"/>
           <p:cNvPicPr>
             <a:picLocks noChangeAspect="1"/>
           </p:cNvPicPr>
           <p:nvPr/>
         </p:nvPicPr>
         <p:blipFill>
-          <a:blip r:embed="rId2"/>
+          <a:blip r:embed="rId3"/>
           <a:stretch>
             <a:fillRect/>
           </a:stretch>
@@ -7105,7 +7105,7 @@
                 </a:solidFill>
                 <a:latin typeface="Aptos"/>
               </a:rPr>
-              <a:t>Saved settings persist and reflect on member-facing waiver flows.</a:t>
+              <a:t>Claim history follows the selected league; permission and loading failures offer a clear retry.</a:t>
             </a:r>
           </a:p>
         </p:txBody>

</xml_diff>